<commit_message>
Deck: fill PS title, team name and GitHub link
</commit_message>
<xml_diff>
--- a/presentation/RAKSHA-PATH X - Seva First Innovation Challenge 2026.pptx
+++ b/presentation/RAKSHA-PATH X - Seva First Innovation Challenge 2026.pptx
@@ -5594,7 +5594,7 @@
         </p:nvSpPr>
         <p:spPr>
           <a:xfrm>
-            <a:off x="331286" y="2076450"/>
+            <a:off x="331286" y="1920240"/>
             <a:ext cx="6766560" cy="4703019"/>
           </a:xfrm>
           <a:prstGeom prst="rect">
@@ -5639,7 +5639,7 @@
           <a:p>
             <a:pPr marL="285750" indent="-285750" algn="l">
               <a:lnSpc>
-                <a:spcPct val="200000"/>
+                <a:spcPct val="100000"/>
               </a:lnSpc>
               <a:buFont typeface="Arial" panose="020B0604020202020204" pitchFamily="34" charset="0"/>
               <a:buChar char="•"/>
@@ -5652,13 +5652,33 @@
               <a:t>Problem Statement Title- </a:t>
             </a:r>
             <a:r>
-              <a:rPr b="0" sz="1600">
-                <a:solidFill>
-                  <a:srgbClr val="C00000"/>
+              <a:rPr b="0" sz="1400">
+                <a:solidFill>
+                  <a:srgbClr val="1A1A1A"/>
                 </a:solidFill>
                 <a:latin typeface="Arial"/>
               </a:rPr>
-              <a:t>[PS Title]</a:t>
+              <a:t>RAKSHA-PATH X:</a:t>
+            </a:r>
+            <a:br/>
+            <a:r>
+              <a:rPr b="0" sz="1400">
+                <a:solidFill>
+                  <a:srgbClr val="1A1A1A"/>
+                </a:solidFill>
+                <a:latin typeface="Arial"/>
+              </a:rPr>
+              <a:t>Intelligent Emergency Route Optimization and</a:t>
+            </a:r>
+            <a:br/>
+            <a:r>
+              <a:rPr b="0" sz="1400">
+                <a:solidFill>
+                  <a:srgbClr val="1A1A1A"/>
+                </a:solidFill>
+                <a:latin typeface="Arial"/>
+              </a:rPr>
+              <a:t>Real-Time Disaster Road Intelligence System</a:t>
             </a:r>
           </a:p>
           <a:p>
@@ -5754,11 +5774,11 @@
             <a:r>
               <a:rPr b="0" sz="1600">
                 <a:solidFill>
-                  <a:srgbClr val="C00000"/>
+                  <a:srgbClr val="1A1A1A"/>
                 </a:solidFill>
                 <a:latin typeface="Arial"/>
               </a:rPr>
-              <a:t>[Team Name]</a:t>
+              <a:t>RAKSHA-PATHX-100</a:t>
             </a:r>
             <a:endParaRPr lang="en-IN" sz="2400" b="1" dirty="0">
               <a:latin typeface="Arial" panose="020B0604020202020204" pitchFamily="34" charset="0"/>
@@ -6113,12 +6133,13 @@
           <a:p>
             <a:pPr algn="ctr"/>
             <a:r>
-              <a:rPr lang="en-US" dirty="0">
-                <a:solidFill>
-                  <a:srgbClr val="C00000"/>
-                </a:solidFill>
-              </a:rPr>
-              <a:t>[Team Name]</a:t>
+              <a:rPr lang="en-US" dirty="0" sz="1100" b="1"/>
+              <a:t>RAKSHA-</a:t>
+            </a:r>
+            <a:br/>
+            <a:r>
+              <a:rPr sz="1100" b="1"/>
+              <a:t>PATHX-100</a:t>
             </a:r>
             <a:endParaRPr lang="en-IN" dirty="0"/>
           </a:p>
@@ -7412,12 +7433,13 @@
           <a:p>
             <a:pPr algn="ctr"/>
             <a:r>
-              <a:rPr lang="en-US" dirty="0">
-                <a:solidFill>
-                  <a:srgbClr val="C00000"/>
-                </a:solidFill>
-              </a:rPr>
-              <a:t>[Team Name]</a:t>
+              <a:rPr lang="en-US" dirty="0" sz="1100" b="1"/>
+              <a:t>RAKSHA-</a:t>
+            </a:r>
+            <a:br/>
+            <a:r>
+              <a:rPr sz="1100" b="1"/>
+              <a:t>PATHX-100</a:t>
             </a:r>
             <a:endParaRPr lang="en-IN" dirty="0"/>
           </a:p>
@@ -9342,12 +9364,13 @@
           <a:p>
             <a:pPr algn="ctr"/>
             <a:r>
-              <a:rPr lang="en-US" dirty="0">
-                <a:solidFill>
-                  <a:srgbClr val="C00000"/>
-                </a:solidFill>
-              </a:rPr>
-              <a:t>[Team Name]</a:t>
+              <a:rPr lang="en-US" dirty="0" sz="1100" b="1"/>
+              <a:t>RAKSHA-</a:t>
+            </a:r>
+            <a:br/>
+            <a:r>
+              <a:rPr sz="1100" b="1"/>
+              <a:t>PATHX-100</a:t>
             </a:r>
             <a:endParaRPr lang="en-IN" dirty="0"/>
           </a:p>
@@ -10972,12 +10995,13 @@
           <a:p>
             <a:pPr algn="ctr"/>
             <a:r>
-              <a:rPr lang="en-US" dirty="0">
-                <a:solidFill>
-                  <a:srgbClr val="C00000"/>
-                </a:solidFill>
-              </a:rPr>
-              <a:t>[Team Name]</a:t>
+              <a:rPr lang="en-US" dirty="0" sz="1100" b="1"/>
+              <a:t>RAKSHA-</a:t>
+            </a:r>
+            <a:br/>
+            <a:r>
+              <a:rPr sz="1100" b="1"/>
+              <a:t>PATHX-100</a:t>
             </a:r>
             <a:endParaRPr lang="en-IN" dirty="0"/>
           </a:p>
@@ -12526,12 +12550,13 @@
           <a:p>
             <a:pPr algn="ctr"/>
             <a:r>
-              <a:rPr lang="en-US" dirty="0">
-                <a:solidFill>
-                  <a:srgbClr val="C00000"/>
-                </a:solidFill>
-              </a:rPr>
-              <a:t>[Team Name]</a:t>
+              <a:rPr lang="en-US" dirty="0" sz="1100" b="1"/>
+              <a:t>RAKSHA-</a:t>
+            </a:r>
+            <a:br/>
+            <a:r>
+              <a:rPr sz="1100" b="1"/>
+              <a:t>PATHX-100</a:t>
             </a:r>
             <a:endParaRPr lang="en-IN" dirty="0"/>
           </a:p>
@@ -13342,11 +13367,11 @@
             <a:r>
               <a:rPr sz="1100" b="0" i="0">
                 <a:solidFill>
-                  <a:srgbClr val="C00000"/>
+                  <a:srgbClr val="2E5597"/>
                 </a:solidFill>
                 <a:latin typeface="Arial"/>
               </a:rPr>
-              <a:t>[GitHub repository URL]</a:t>
+              <a:t>https://github.com/Abishekh2007/sewa-</a:t>
             </a:r>
           </a:p>
           <a:p>

</xml_diff>